<commit_message>
docs: refine submission assets and clean repository history
</commit_message>
<xml_diff>
--- a/docs/Presentation_XJCO3011.pptx
+++ b/docs/Presentation_XJCO3011.pptx
@@ -3401,6 +3401,12 @@
             <a:pPr lvl="1"/>
             <a:r>
               <a:t>4816579 Document project setup and deployment workflow</a:t>
+            </a:r>
+          </a:p>
+          <a:p>
+            <a:pPr lvl="1"/>
+            <a:r>
+              <a:t>49b39ac Add submission report presentation and API documentation</a:t>
             </a:r>
           </a:p>
         </p:txBody>

</xml_diff>

<commit_message>
docs: polish technical report and presentation narrative
</commit_message>
<xml_diff>
--- a/docs/Presentation_XJCO3011.pptx
+++ b/docs/Presentation_XJCO3011.pptx
@@ -3139,6 +3139,11 @@
               <a:t>Student ID: 339919905</a:t>
             </a:r>
           </a:p>
+          <a:p>
+            <a:r>
+              <a:t>FastAPI + SQLAlchemy + SQLite</a:t>
+            </a:r>
+          </a:p>
         </p:txBody>
       </p:sp>
     </p:spTree>
@@ -3175,7 +3180,7 @@
           <a:lstStyle/>
           <a:p>
             <a:r>
-              <a:t>Project Overview</a:t>
+              <a:t>Project Aim and Scope</a:t>
             </a:r>
           </a:p>
         </p:txBody>
@@ -3196,31 +3201,31 @@
           <a:lstStyle/>
           <a:p>
             <a:r>
-              <a:t>A data-driven FastAPI Web API for managing tasks.</a:t>
+              <a:t>Build a data-driven Web API that satisfies the coursework requirements.</a:t>
             </a:r>
           </a:p>
           <a:p>
             <a:pPr lvl="1"/>
             <a:r>
-              <a:t>SQLite used for local persistent storage.</a:t>
+              <a:t>One core resource: Task</a:t>
             </a:r>
           </a:p>
           <a:p>
             <a:pPr lvl="1"/>
             <a:r>
-              <a:t>SQLAlchemy used as the ORM layer.</a:t>
+              <a:t>Full CRUD support with database persistence</a:t>
             </a:r>
           </a:p>
           <a:p>
             <a:pPr lvl="1"/>
             <a:r>
-              <a:t>Pydantic validates request and response data.</a:t>
+              <a:t>JSON responses, validation, and status codes</a:t>
             </a:r>
           </a:p>
           <a:p>
             <a:pPr lvl="1"/>
             <a:r>
-              <a:t>Swagger /docs provides interactive API documentation.</a:t>
+              <a:t>Interactive documentation through /docs and /redoc</a:t>
             </a:r>
           </a:p>
         </p:txBody>
@@ -3259,7 +3264,7 @@
           <a:lstStyle/>
           <a:p>
             <a:r>
-              <a:t>System Architecture</a:t>
+              <a:t>Architecture and Design</a:t>
             </a:r>
           </a:p>
         </p:txBody>
@@ -3280,31 +3285,31 @@
           <a:lstStyle/>
           <a:p>
             <a:r>
+              <a:t>The system follows a simple but modular backend architecture:</a:t>
+            </a:r>
+          </a:p>
+          <a:p>
+            <a:pPr lvl="1"/>
+            <a:r>
               <a:t>Client -&gt; FastAPI routes -&gt; SQLAlchemy ORM -&gt; SQLite database</a:t>
             </a:r>
           </a:p>
           <a:p>
             <a:pPr lvl="1"/>
             <a:r>
-              <a:t>main.py starts the application and exception handlers.</a:t>
+              <a:t>Pydantic validates request and response payloads</a:t>
             </a:r>
           </a:p>
           <a:p>
             <a:pPr lvl="1"/>
             <a:r>
-              <a:t>routers/items.py contains CRUD endpoint logic.</a:t>
+              <a:t>main.py configures middleware, exception handling, and startup</a:t>
             </a:r>
           </a:p>
           <a:p>
             <a:pPr lvl="1"/>
             <a:r>
-              <a:t>database.py defines the Task model and session handling.</a:t>
-            </a:r>
-          </a:p>
-          <a:p>
-            <a:pPr lvl="1"/>
-            <a:r>
-              <a:t>schemas.py defines validated API payloads.</a:t>
+              <a:t>Routing, schemas, and database logic are separated into modules</a:t>
             </a:r>
           </a:p>
         </p:txBody>
@@ -3343,7 +3348,7 @@
           <a:lstStyle/>
           <a:p>
             <a:r>
-              <a:t>Version Control Evidence</a:t>
+              <a:t>Feature Set Delivered</a:t>
             </a:r>
           </a:p>
         </p:txBody>
@@ -3364,49 +3369,37 @@
           <a:lstStyle/>
           <a:p>
             <a:r>
-              <a:t>Structured Git history demonstrates staged development:</a:t>
+              <a:t>The API goes beyond the minimum CRUD requirement:</a:t>
             </a:r>
           </a:p>
           <a:p>
             <a:pPr lvl="1"/>
             <a:r>
-              <a:t>8ca73e4 Initialize coursework API repository</a:t>
+              <a:t>Create, read, update, patch, and delete task records</a:t>
             </a:r>
           </a:p>
           <a:p>
             <a:pPr lvl="1"/>
             <a:r>
-              <a:t>a06c6a7 Add database configuration and task schemas</a:t>
+              <a:t>Pagination using page and limit query parameters</a:t>
             </a:r>
           </a:p>
           <a:p>
             <a:pPr lvl="1"/>
             <a:r>
-              <a:t>a7cf785 Implement CRUD task API endpoints</a:t>
+              <a:t>Search and filter support on task listings</a:t>
             </a:r>
           </a:p>
           <a:p>
             <a:pPr lvl="1"/>
             <a:r>
-              <a:t>2e79950 Add sample seed data for local demonstrations</a:t>
+              <a:t>Timestamp fields for auditability</a:t>
             </a:r>
           </a:p>
           <a:p>
             <a:pPr lvl="1"/>
             <a:r>
-              <a:t>10a11b3 Add automated API tests with isolated database</a:t>
-            </a:r>
-          </a:p>
-          <a:p>
-            <a:pPr lvl="1"/>
-            <a:r>
-              <a:t>4816579 Document project setup and deployment workflow</a:t>
-            </a:r>
-          </a:p>
-          <a:p>
-            <a:pPr lvl="1"/>
-            <a:r>
-              <a:t>49b39ac Add submission report presentation and API documentation</a:t>
+              <a:t>Standardized JSON error responses</a:t>
             </a:r>
           </a:p>
         </p:txBody>
@@ -3445,7 +3438,7 @@
           <a:lstStyle/>
           <a:p>
             <a:r>
-              <a:t>API Features Demonstrated</a:t>
+              <a:t>Evidence of Version Control</a:t>
             </a:r>
           </a:p>
         </p:txBody>
@@ -3466,37 +3459,55 @@
           <a:lstStyle/>
           <a:p>
             <a:r>
-              <a:t>Implemented endpoints and enhanced API behaviour:</a:t>
+              <a:t>Git history shows a staged development process:</a:t>
             </a:r>
           </a:p>
           <a:p>
             <a:pPr lvl="1"/>
             <a:r>
-              <a:t>Complete CRUD for the Task resource</a:t>
+              <a:t>8ca73e4 Initialize coursework API repository</a:t>
             </a:r>
           </a:p>
           <a:p>
             <a:pPr lvl="1"/>
             <a:r>
-              <a:t>Pagination using page and limit query parameters</a:t>
+              <a:t>a06c6a7 Add database configuration and task schemas</a:t>
             </a:r>
           </a:p>
           <a:p>
             <a:pPr lvl="1"/>
             <a:r>
-              <a:t>Search and filter support on task listings</a:t>
+              <a:t>a7cf785 Implement CRUD task API endpoints</a:t>
             </a:r>
           </a:p>
           <a:p>
             <a:pPr lvl="1"/>
             <a:r>
-              <a:t>PATCH support for partial updates</a:t>
+              <a:t>2e79950 Add sample seed data for local demonstrations</a:t>
             </a:r>
           </a:p>
           <a:p>
             <a:pPr lvl="1"/>
             <a:r>
-              <a:t>Standardized error responses and timestamps</a:t>
+              <a:t>10a11b3 Add automated API tests with isolated database</a:t>
+            </a:r>
+          </a:p>
+          <a:p>
+            <a:pPr lvl="1"/>
+            <a:r>
+              <a:t>4816579 Document project setup and deployment workflow</a:t>
+            </a:r>
+          </a:p>
+          <a:p>
+            <a:pPr lvl="1"/>
+            <a:r>
+              <a:t>49b39ac Add submission report presentation and API documentation</a:t>
+            </a:r>
+          </a:p>
+          <a:p>
+            <a:pPr lvl="1"/>
+            <a:r>
+              <a:t>5b7417f Refine submission assets and clean repository history</a:t>
             </a:r>
           </a:p>
         </p:txBody>
@@ -3556,31 +3567,31 @@
           <a:lstStyle/>
           <a:p>
             <a:r>
-              <a:t>Automated tests were implemented with pytest.</a:t>
+              <a:t>Testing was used as evidence that the API is reliable.</a:t>
             </a:r>
           </a:p>
           <a:p>
             <a:pPr lvl="1"/>
             <a:r>
-              <a:t>10 automated tests pass successfully.</a:t>
+              <a:t>pytest and FastAPI TestClient were used</a:t>
             </a:r>
           </a:p>
           <a:p>
             <a:pPr lvl="1"/>
             <a:r>
-              <a:t>TestClient used for endpoint verification.</a:t>
+              <a:t>10 automated tests cover core API behaviour</a:t>
             </a:r>
           </a:p>
           <a:p>
             <a:pPr lvl="1"/>
             <a:r>
-              <a:t>Temporary SQLite database isolates tests from development data.</a:t>
+              <a:t>A temporary SQLite database isolates tests from development data</a:t>
             </a:r>
           </a:p>
           <a:p>
             <a:pPr lvl="1"/>
             <a:r>
-              <a:t>Covers CRUD, filtering, 404 handling, and validation errors.</a:t>
+              <a:t>The suite covers CRUD, filtering, 404 responses, and validation errors</a:t>
             </a:r>
           </a:p>
         </p:txBody>
@@ -3619,7 +3630,7 @@
           <a:lstStyle/>
           <a:p>
             <a:r>
-              <a:t>Reflection and Next Steps</a:t>
+              <a:t>Reflection and Future Improvements</a:t>
             </a:r>
           </a:p>
         </p:txBody>
@@ -3640,31 +3651,31 @@
           <a:lstStyle/>
           <a:p>
             <a:r>
-              <a:t>Project outcomes and future improvements:</a:t>
+              <a:t>The project meets the core coursework goals and provides a solid backend foundation.</a:t>
             </a:r>
           </a:p>
           <a:p>
             <a:pPr lvl="1"/>
             <a:r>
-              <a:t>The project satisfies the core Web API coursework requirements.</a:t>
+              <a:t>Strengths: modular structure, testing, documentation, and clear API behaviour</a:t>
             </a:r>
           </a:p>
           <a:p>
             <a:pPr lvl="1"/>
             <a:r>
-              <a:t>AI assistance supported scaffolding, testing ideas, and documentation drafting.</a:t>
+              <a:t>Limitation: SQLite is suitable for coursework but not ideal for higher-scale production use</a:t>
             </a:r>
           </a:p>
           <a:p>
             <a:pPr lvl="1"/>
             <a:r>
-              <a:t>The final system was run, verified, and refined manually before submission.</a:t>
+              <a:t>Missing feature: authentication and user ownership of tasks</a:t>
             </a:r>
           </a:p>
           <a:p>
             <a:pPr lvl="1"/>
             <a:r>
-              <a:t>Future work: deploy to Render, add authentication, and migrate to PostgreSQL.</a:t>
+              <a:t>Future work: deploy to Render, add JWT auth, and migrate to PostgreSQL</a:t>
             </a:r>
           </a:p>
         </p:txBody>

</xml_diff>

<commit_message>
docs: add presentation PDF and align submission assets
</commit_message>
<xml_diff>
--- a/docs/Presentation_XJCO3011.pptx
+++ b/docs/Presentation_XJCO3011.pptx
@@ -12,6 +12,7 @@
     <p:sldId id="260" r:id="rId11"/>
     <p:sldId id="261" r:id="rId12"/>
     <p:sldId id="262" r:id="rId13"/>
+    <p:sldId id="263" r:id="rId14"/>
   </p:sldIdLst>
   <p:sldSz cx="9144000" cy="6858000" type="screen4x3"/>
   <p:notesSz cx="6858000" cy="9144000"/>
@@ -3546,7 +3547,7 @@
           <a:lstStyle/>
           <a:p>
             <a:r>
-              <a:t>Testing and Quality Assurance</a:t>
+              <a:t>Version Control Screenshot Evidence</a:t>
             </a:r>
           </a:p>
         </p:txBody>
@@ -3567,31 +3568,25 @@
           <a:lstStyle/>
           <a:p>
             <a:r>
-              <a:t>Testing was used as evidence that the API is reliable.</a:t>
+              <a:t>Before the final presentation, this slide should include a screenshot of git log --oneline or the GitHub commits page.</a:t>
             </a:r>
           </a:p>
           <a:p>
             <a:pPr lvl="1"/>
             <a:r>
-              <a:t>pytest and FastAPI TestClient were used</a:t>
+              <a:t>Use the screenshot to show that version control was actively used.</a:t>
             </a:r>
           </a:p>
           <a:p>
             <a:pPr lvl="1"/>
             <a:r>
-              <a:t>10 automated tests cover core API behaviour</a:t>
+              <a:t>Highlight repository setup, schema work, endpoint implementation, testing, and documentation.</a:t>
             </a:r>
           </a:p>
           <a:p>
             <a:pPr lvl="1"/>
             <a:r>
-              <a:t>A temporary SQLite database isolates tests from development data</a:t>
-            </a:r>
-          </a:p>
-          <a:p>
-            <a:pPr lvl="1"/>
-            <a:r>
-              <a:t>The suite covers CRUD, filtering, 404 responses, and validation errors</a:t>
+              <a:t>This slide acts as direct evidence for the coursework version control requirement.</a:t>
             </a:r>
           </a:p>
         </p:txBody>
@@ -3605,6 +3600,90 @@
 </file>
 
 <file path=ppt/slides/slide7.xml><?xml version="1.0" encoding="utf-8"?>
+<p:sld xmlns:a="http://schemas.openxmlformats.org/drawingml/2006/main" xmlns:p="http://schemas.openxmlformats.org/presentationml/2006/main" xmlns:r="http://schemas.openxmlformats.org/officeDocument/2006/relationships">
+  <p:cSld>
+    <p:spTree>
+      <p:nvGrpSpPr>
+        <p:cNvPr id="1" name=""/>
+        <p:cNvGrpSpPr/>
+        <p:nvPr/>
+      </p:nvGrpSpPr>
+      <p:grpSpPr/>
+      <p:sp>
+        <p:nvSpPr>
+          <p:cNvPr id="2" name="Title 1"/>
+          <p:cNvSpPr>
+            <a:spLocks noGrp="1"/>
+          </p:cNvSpPr>
+          <p:nvPr>
+            <p:ph type="title"/>
+          </p:nvPr>
+        </p:nvSpPr>
+        <p:spPr/>
+        <p:txBody>
+          <a:bodyPr/>
+          <a:lstStyle/>
+          <a:p>
+            <a:r>
+              <a:t>Testing and Quality Assurance</a:t>
+            </a:r>
+          </a:p>
+        </p:txBody>
+      </p:sp>
+      <p:sp>
+        <p:nvSpPr>
+          <p:cNvPr id="3" name="Content Placeholder 2"/>
+          <p:cNvSpPr>
+            <a:spLocks noGrp="1"/>
+          </p:cNvSpPr>
+          <p:nvPr>
+            <p:ph idx="1"/>
+          </p:nvPr>
+        </p:nvSpPr>
+        <p:spPr/>
+        <p:txBody>
+          <a:bodyPr/>
+          <a:lstStyle/>
+          <a:p>
+            <a:r>
+              <a:t>Testing was used as evidence that the API is reliable.</a:t>
+            </a:r>
+          </a:p>
+          <a:p>
+            <a:pPr lvl="1"/>
+            <a:r>
+              <a:t>pytest and FastAPI TestClient were used</a:t>
+            </a:r>
+          </a:p>
+          <a:p>
+            <a:pPr lvl="1"/>
+            <a:r>
+              <a:t>10 automated tests cover core API behaviour</a:t>
+            </a:r>
+          </a:p>
+          <a:p>
+            <a:pPr lvl="1"/>
+            <a:r>
+              <a:t>A temporary SQLite database isolates tests from development data</a:t>
+            </a:r>
+          </a:p>
+          <a:p>
+            <a:pPr lvl="1"/>
+            <a:r>
+              <a:t>The suite covers CRUD, filtering, 404 responses, and validation errors</a:t>
+            </a:r>
+          </a:p>
+        </p:txBody>
+      </p:sp>
+    </p:spTree>
+  </p:cSld>
+  <p:clrMapOvr>
+    <a:masterClrMapping/>
+  </p:clrMapOvr>
+</p:sld>
+</file>
+
+<file path=ppt/slides/slide8.xml><?xml version="1.0" encoding="utf-8"?>
 <p:sld xmlns:a="http://schemas.openxmlformats.org/drawingml/2006/main" xmlns:p="http://schemas.openxmlformats.org/presentationml/2006/main" xmlns:r="http://schemas.openxmlformats.org/officeDocument/2006/relationships">
   <p:cSld>
     <p:spTree>

</xml_diff>